<commit_message>
Fix all citations and enhance presenter notes with verified references
Major citation corrections:
- Ren et al. 2024: Chemical Science → Nature Biotechnology (ISM001-055)
- Santos et al. 2017: ~18% → ~6% for ion channel drug targets
- Nat.Neurosci. 2023: first author Ammer (not Haag), pages 1894-1905
- Marzullo & Gage 2012: Adv. Physiol. Educ. → PLoS ONE 7(3):e30837
- DiffDock: Corso et al. 2022 → 2023, ICLR
- Gaulton/ChEMBL: D986-D994 → D945-D954
- Bessadok: Med. Image Anal. 2022 → IEEE T-PAMI 45:5833-5848 (2023)
- Kipf & Welling GCN: ~12K → ~56K citations
- McKinsey 2021 → MGI Bio Revolution (2020) + 2022 analyses
- Added full doi/volume/page for all major citations in notes
- Enhanced presenter notes with detailed talking points for master students

Agent-Logs-Url: https://github.com/ETigerschuss/AI-Drug-Discovery/sessions/dbf5c3b1-6d10-4732-9dbd-e3279c8eda32

Co-authored-by: ETigerschuss <3415055+ETigerschuss@users.noreply.github.com>
</commit_message>
<xml_diff>
--- a/day1_introduction/slides.pptx
+++ b/day1_introduction/slides.pptx
@@ -546,22 +546,22 @@
           </a:p>
           <a:p>
             <a:r>
-              <a:t>- 'Multilevel visual motion opponency in Drosophila' (Nature Neuroscience, 2023) — GluClα-mediated inhibition in direction-selective circuits</a:t>
-            </a:r>
-          </a:p>
-          <a:p>
-            <a:r>
-              <a:t>- 'Voltage to Calcium Transformation Enhances Direction Selectivity in Drosophila T4 Neurons' (J. Neurosci., 2023)</a:t>
-            </a:r>
-          </a:p>
-          <a:p>
-            <a:r>
-              <a:t>- 'Comprehensive Characterization of the Major Presynaptic Elements to the Drosophila OFF Motion Detector' (Neuron, 2016) — this is a PHYSIOLOGY paper: used calcium imaging, electrophysiology, and optogenetics to characterize the functional properties of neurons providing input to T5 motion detectors</a:t>
-            </a:r>
-          </a:p>
-          <a:p>
-            <a:r>
-              <a:t>- 'A Directional Tuning Map of Drosophila Elementary Motion Detectors' (Nature, 2013)</a:t>
+              <a:t>- Ammer, Serbe-Kamp et al. (2023) 'Multilevel visual motion opponency in Drosophila.' Nature Neuroscience 26:1894-1905 — showed that GluClα-mediated inhibition underlies direction-opponent responses at all levels of the motion circuit</a:t>
+            </a:r>
+          </a:p>
+          <a:p>
+            <a:r>
+              <a:t>- Serbe-Kamp et al. (2023) 'Voltage to Calcium Transformation Enhances Direction Selectivity in Drosophila T4 Neurons.' J. Neurosci. 43:2497-2514 — demonstrated a nonlinear voltage-to-calcium transformation that enhances direction selectivity</a:t>
+            </a:r>
+          </a:p>
+          <a:p>
+            <a:r>
+              <a:t>- Serbe et al. (2016) 'Comprehensive Characterization of the Major Presynaptic Elements to the Drosophila OFF Motion Detector.' Neuron 89:829-841 — this is a PHYSIOLOGY paper: used calcium imaging (GCaMP), whole-cell patch-clamp electrophysiology, and optogenetics (CsChrimson, GtACR1) to functionally characterize the neurons providing input to T5 motion detectors</a:t>
+            </a:r>
+          </a:p>
+          <a:p>
+            <a:r>
+              <a:t>- Maisak, Haag, Ammer, Serbe et al. (2013) 'A Directional Tuning Map of Drosophila Elementary Motion Detectors.' Nature 500:212-216</a:t>
             </a:r>
           </a:p>
           <a:p/>
@@ -573,7 +573,17 @@
           <a:p/>
           <a:p>
             <a:r>
-              <a:t>He is also Co-Director of Summer Fellowships at Backyard Brains, developing open-source neuroscience tools (SpikerBox/SpikerBot). Recent citizen science work: 'A Library of Electrophysiological Responses in Plants' (Plant Signaling &amp; Behavior, 2024).</a:t>
+              <a:t>He is also Co-Director of Summer Fellowships at Backyard Brains, developing open-source neuroscience tools (SpikerBox/SpikerBot). Recent work:</a:t>
+            </a:r>
+          </a:p>
+          <a:p>
+            <a:r>
+              <a:t>- Madariaga, [...], Serbe-Kamp, Marzullo (2024) 'A library of electrophysiological responses in plants.' Plant Signaling &amp; Behavior 19(1):2310977</a:t>
+            </a:r>
+          </a:p>
+          <a:p>
+            <a:r>
+              <a:t>- Serbe-Kamp et al. (2023) 'Open Citizen Science: fostering open knowledge with participation.' Research Ideas and Outcomes 9:e96476</a:t>
             </a:r>
           </a:p>
           <a:p/>
@@ -661,6 +671,12 @@
           <a:p/>
           <a:p>
             <a:r>
+              <a:t>CITATION: ChEMBL: Gaulton et al. (2017) 'The ChEMBL database in 2017.' Nucleic Acids Res. 45(D1):D945-D954. Latest release (ChEMBL 35, Dec 2024) contains ~2.5M compounds.</a:t>
+            </a:r>
+          </a:p>
+          <a:p/>
+          <a:p>
+            <a:r>
               <a:t>=== PHYSIOLOGY AS DRUG READOUT — KEY THEME ===</a:t>
             </a:r>
           </a:p>
@@ -672,19 +688,19 @@
           <a:p/>
           <a:p>
             <a:r>
-              <a:t>1. PATCH-CLAMP ELECTROPHYSIOLOGY: Gold standard for ion channel drugs. Measure current through channels, add drug, measure IC50. This is exactly what Dr. Serbe-Kamp's 2016 Neuron paper used — whole-cell recordings + optogenetics to characterize T5 neuron inputs. For hERG cardiac safety testing: patch-clamp HEK293 cells, measure block IC50.</a:t>
+              <a:t>1. PATCH-CLAMP ELECTROPHYSIOLOGY: Gold standard for ion channel drugs. Measure current through channels, add drug, measure IC50. This is exactly what Dr. Serbe-Kamp's 2016 Neuron paper used — whole-cell recordings + optogenetics to characterize T5 neuron inputs (Serbe et al. 2016, Neuron 89:829-841). For hERG cardiac safety testing: patch-clamp HEK293 cells, measure block IC50.</a:t>
             </a:r>
           </a:p>
           <a:p/>
           <a:p>
             <a:r>
-              <a:t>2. CALCIUM IMAGING: Dr. Serbe-Kamp's 2023 J.Neurosci. paper used two-photon calcium imaging in Drosophila T4 neurons. Same technique used in drug screening (FLIPR assays for GPCR screens).</a:t>
+              <a:t>2. CALCIUM IMAGING: Dr. Serbe-Kamp's 2023 J.Neurosci. paper (43:2497-2514) used two-photon calcium imaging in Drosophila T4 neurons. Same technique used in drug screening (FLIPR assays for GPCR screens).</a:t>
             </a:r>
           </a:p>
           <a:p/>
           <a:p>
             <a:r>
-              <a:t>3. EXTRACELLULAR RECORDING: The SpikerBox records extracellular spikes from neurons/muscles. Apply a drug (e.g., lidocaine = Nav blocker) and watch the action potentials disappear. This IS drug effect measurement!</a:t>
+              <a:t>3. EXTRACELLULAR RECORDING: The SpikerBox records extracellular spikes from neurons/muscles. Apply a drug (e.g., lidocaine = Nav blocker) and watch the action potentials disappear. This IS drug effect measurement! Ref: Marzullo &amp; Gage (2012) PLoS ONE 7(3):e30837.</a:t>
             </a:r>
           </a:p>
           <a:p/>
@@ -1009,22 +1025,22 @@
           </a:p>
           <a:p>
             <a:r>
-              <a:t>1. Maisak, Haag, Ammer, Serbe et al. (2013, Nature 500:212-216) — directional tuning map of T4/T5 neurons</a:t>
-            </a:r>
-          </a:p>
-          <a:p>
-            <a:r>
-              <a:t>2. Serbe et al. (2016, Neuron 89:829-841) — PHYSIOLOGY paper: calcium imaging, electrophysiology, optogenetics characterizing T5 inputs</a:t>
-            </a:r>
-          </a:p>
-          <a:p>
-            <a:r>
-              <a:t>3. Haag, Arenz, Serbe-Kamp et al. (2023, Nature Neurosci. 26:1894-1903) — GluClα mediates motion opponency</a:t>
-            </a:r>
-          </a:p>
-          <a:p>
-            <a:r>
-              <a:t>4. Serbe-Kamp et al. (2023, J. Neurosci. 43:2497-2514) — voltage-to-calcium transformation</a:t>
+              <a:t>1. Maisak, Haag, Ammer, Serbe et al. (2013, Nature 500:212-216) — directional tuning map of T4/T5 neurons. The first paper to show that T4 and T5 cells are the elementary motion detectors of the fly visual system.</a:t>
+            </a:r>
+          </a:p>
+          <a:p>
+            <a:r>
+              <a:t>2. Serbe et al. (2016, Neuron 89:829-841) — PHYSIOLOGY paper: calcium imaging (GCaMP6f, two-photon), whole-cell patch-clamp electrophysiology, and optogenetics (CsChrimson, GtACR1) to characterize T5 motion detector inputs. This is NOT connectomics.</a:t>
+            </a:r>
+          </a:p>
+          <a:p>
+            <a:r>
+              <a:t>3. Ammer, Serbe-Kamp et al. (2023, Nature Neurosci. 26:1894-1905) — GluClα mediates motion-opponent inhibition at all levels of the Drosophila motion pathway</a:t>
+            </a:r>
+          </a:p>
+          <a:p>
+            <a:r>
+              <a:t>4. Serbe-Kamp et al. (2023, J. Neurosci. 43:2497-2514) — demonstrated that nonlinear voltage-to-calcium transformation in T4 neurons sharpens directional tuning</a:t>
             </a:r>
           </a:p>
           <a:p/>
@@ -1041,7 +1057,7 @@
           </a:p>
           <a:p>
             <a:r>
-              <a:t>GluCl is in the Cys-loop receptor superfamily (same as GABA-A). Ivermectin locks GluCl open → Cl- influx → paralysis in parasites. 2015 Nobel Prize (Ōmura &amp; Campbell). Dr. Serbe-Kamp's 2023 Nat.Neurosci. paper found GluClα mediates inhibition in Drosophila motion circuits.</a:t>
+              <a:t>GluCl is a glutamate-gated chloride channel in the Cys-loop receptor superfamily (same family as GABA-A, glycine receptors, nAChR). Ivermectin locks GluCl open → Cl⁻ influx → hyperpolarization → paralysis in parasites. 2015 Nobel Prize in Physiology or Medicine (Satoshi Ōmura &amp; William C. Campbell) for the discovery of avermectin/ivermectin. Dr. Serbe-Kamp's 2023 Nat.Neurosci. paper (Ammer, Serbe-Kamp et al., 26:1894-1905) found GluClα mediates inhibition in Drosophila motion circuits — same channel family, different organism, different function.</a:t>
             </a:r>
           </a:p>
           <a:p/>
@@ -1052,12 +1068,48 @@
           </a:p>
           <a:p>
             <a:r>
-              <a:t>C_m * dV/dt = -g_Na*m³h*(V-E_Na) - g_K*n⁴*(V-E_K) - g_L*(V-E_L) + I_ext</a:t>
-            </a:r>
-          </a:p>
-          <a:p>
-            <a:r>
-              <a:t>Drug effects = modifying conductance parameters. We simulate this in the practical.</a:t>
+              <a:t>CITATION: Hodgkin &amp; Huxley (1952) 'A quantitative description of membrane current and its application to conduction and excitation in nerve.' J. Physiol. 117:500-544. Won the 1963 Nobel Prize in Physiology or Medicine (shared with John Eccles).</a:t>
+            </a:r>
+          </a:p>
+          <a:p>
+            <a:r>
+              <a:t>Equation: C_m * dV/dt = -g_Na*m³h*(V-E_Na) - g_K*n⁴*(V-E_K) - g_L*(V-E_L) + I_ext</a:t>
+            </a:r>
+          </a:p>
+          <a:p>
+            <a:r>
+              <a:t>Drug effects = modifying conductance parameters (g_Na, g_K). For example:</a:t>
+            </a:r>
+          </a:p>
+          <a:p>
+            <a:r>
+              <a:t>- Lidocaine (Nav blocker): reduce g_Na → fewer/no action potentials</a:t>
+            </a:r>
+          </a:p>
+          <a:p>
+            <a:r>
+              <a:t>- 4-aminopyridine (Kv blocker): reduce g_K → broader action potentials</a:t>
+            </a:r>
+          </a:p>
+          <a:p>
+            <a:r>
+              <a:t>- Tetrodotoxin (TTX, pufferfish toxin): completely blocks Nav → no firing</a:t>
+            </a:r>
+          </a:p>
+          <a:p>
+            <a:r>
+              <a:t>We simulate this in the Day 1 practical!</a:t>
+            </a:r>
+          </a:p>
+          <a:p/>
+          <a:p>
+            <a:r>
+              <a:t>=== SPIKERBOX ===</a:t>
+            </a:r>
+          </a:p>
+          <a:p>
+            <a:r>
+              <a:t>CITATION: Marzullo &amp; Gage (2012) 'The SpikerBox: A Low Cost, Open-Source BioAmplifier for Increasing Public Participation in Neuroscience Inquiry.' PLoS ONE 7(3):e30837. Note: published in PLoS ONE, not Advances in Physiology Education.</a:t>
             </a:r>
           </a:p>
         </p:txBody>
@@ -2258,19 +2310,25 @@
           <a:p/>
           <a:p>
             <a:r>
+              <a:t>CITATION CHECK: DiMasi, Grabowski &amp; Hansen (2016) 'Innovation in the pharmaceutical industry: New estimates of R&amp;D costs.' J. Health Economics 47:20-33. The $2.6B figure is the commonly rounded version of their $2.558B out-of-pocket estimate ($2.87B capitalized, in 2013 dollars). The ~7.9% Phase I-to-approval success rate comes from BIO/Informa Pharma Intelligence/QLS Advisors (2021) 'Clinical Development Success Rates 2011-2020.'</a:t>
+            </a:r>
+          </a:p>
+          <a:p/>
+          <a:p>
+            <a:r>
               <a:t>Let the numbers sink in. Ask: does anyone know how much a Phase III trial costs? ($50-100M+). Point out the key theme: no matter how good your AI model is at predicting molecular properties, the FINAL validation is always physiological — does the drug actually change cell/tissue/organ function?</a:t>
             </a:r>
           </a:p>
           <a:p/>
           <a:p>
             <a:r>
-              <a:t>This is why physiology matters for drug design: electrophysiology (patch-clamp, extracellular recording) is the gold standard for ion channel drugs. Calcium imaging measures receptor activation. These are EXACTLY the techniques in Dr. Serbe-Kamp's 2016 Neuron paper and 2023 J.Neurosci. paper.</a:t>
+              <a:t>This is why physiology matters for drug design: electrophysiology (patch-clamp, extracellular recording) is the gold standard for ion channel drugs. Calcium imaging measures receptor activation. These are EXACTLY the techniques in Dr. Serbe-Kamp's 2016 Neuron paper (Serbe et al., Neuron 89:829-841) and 2023 J.Neurosci. paper (Serbe-Kamp et al., J. Neurosci. 43:2497-2514).</a:t>
             </a:r>
           </a:p>
           <a:p/>
           <a:p>
             <a:r>
-              <a:t>The Backyard Brains SpikerBox/SpikerBot offer a DIY version of these physiological readouts — making the final step of drug testing accessible.</a:t>
+              <a:t>The Backyard Brains SpikerBox/SpikerBot offer a DIY version of these physiological readouts — making the final step of drug testing accessible. SpikerBox ref: Marzullo &amp; Gage (2012) PLoS ONE 7(3):e30837.</a:t>
             </a:r>
           </a:p>
         </p:txBody>
@@ -2428,7 +2486,19 @@
           <a:p/>
           <a:p>
             <a:r>
-              <a:t>Go through each bullet with examples. The Insilico Medicine case (Ren et al. 2024, Chemical Science) is landmark: AI identified a novel target (TNIK for IPF) AND designed the molecule. End-to-end AI-driven discovery.</a:t>
+              <a:t>CITATION: The McKinsey figures come from McKinsey Global Institute 'The Bio Revolution' (May 2020) and the follow-up 'How AI could revolutionize drug discovery' (McKinsey, 2022). The exact '2-4 years' and '30-50%' numbers are synthesized from these analyses — they are estimates, not precise measurements. Be honest about this with students.</a:t>
+            </a:r>
+          </a:p>
+          <a:p/>
+          <a:p>
+            <a:r>
+              <a:t>CITATION: Insilico Medicine ISM001-055 (Rentosertib). Published as: Ren et al. (2024) 'A small-molecule TNIK inhibitor targets fibrosis in preclinical and clinical models.' Nature Biotechnology. doi:10.1038/s41587-024-02143-0. The drug is a first-in-class TNIK inhibitor for idiopathic pulmonary fibrosis (IPF). Project started ~late 2020, reached Phase IIa enrollment in April 2023 (~30 months). Phase IIa results (71 patients, NCT05938920) were positive, announced September 2024. NOTE: Published in Nature Biotechnology, NOT Chemical Science.</a:t>
+            </a:r>
+          </a:p>
+          <a:p/>
+          <a:p>
+            <a:r>
+              <a:t>Go through each bullet with examples. The Insilico case is landmark: AI identified a novel target (TNIK) AND designed the molecule. End-to-end AI-driven discovery.</a:t>
             </a:r>
           </a:p>
           <a:p/>
@@ -2516,13 +2586,19 @@
           <a:p/>
           <a:p>
             <a:r>
-              <a:t>Jumper et al. (2021) Nature 596:583-589. Won the 2024 Nobel Prize for Hassabis and Jumper. AlphaFold3 (Abramson et al. 2024) extends to protein-ligand complexes.</a:t>
+              <a:t>CITATION: Jumper et al. (2021) 'Highly accurate protein structure prediction with AlphaFold.' Nature 596:583-589. doi:10.1038/s41586-021-03819-2. Won the 2024 Nobel Prize in Chemistry for Demis Hassabis and John Jumper (shared with David Baker for computational protein design).</a:t>
             </a:r>
           </a:p>
           <a:p/>
           <a:p>
             <a:r>
-              <a:t>Neuroscience connection: GluCl (from Dr. Serbe-Kamp's Drosophila research, Cys-loop receptor superfamily) can be modeled. GABA-A receptors, GPCRs (serotonin, dopamine receptors), all benefit.</a:t>
+              <a:t>CITATION: AlphaFold3: Abramson et al. (2024) 'Accurate structure prediction of biomolecular interactions with AlphaFold 3.' Nature 630:493-500. doi:10.1038/s41586-024-07487-w. Extends to protein-ligand, protein-DNA, protein-RNA complexes.</a:t>
+            </a:r>
+          </a:p>
+          <a:p/>
+          <a:p>
+            <a:r>
+              <a:t>Neuroscience connection: GluCl (from Dr. Serbe-Kamp's Drosophila research, Cys-loop receptor superfamily) can be modeled. GABA-A receptors, GPCRs (serotonin 5-HT2A, dopamine D2 receptors), all benefit. About 34% of all FDA-approved drugs target GPCRs (Saikia et al. 2019, Curr. Drug Targets 20:522-539).</a:t>
             </a:r>
           </a:p>
           <a:p/>
@@ -6283,7 +6359,7 @@
               </a:defRPr>
             </a:pPr>
             <a:r>
-              <a:t>Databases: ChEMBL (&gt;2.4M compounds), PubChem (&gt;110M), BindingDB</a:t>
+              <a:t>Databases: ChEMBL (~2.5M compounds), PubChem (&gt;110M), BindingDB</a:t>
             </a:r>
           </a:p>
           <a:p>
@@ -7037,7 +7113,7 @@
               </a:defRPr>
             </a:pPr>
             <a:r>
-              <a:t>Ion channels are major drug targets (~18% of all approved drugs):</a:t>
+              <a:t>Ion channels are important drug targets (Santos et al. 2017: ~6% of efficacy targets):</a:t>
             </a:r>
           </a:p>
           <a:p>
@@ -7098,7 +7174,7 @@
               </a:defRPr>
             </a:pPr>
             <a:r>
-              <a:t>Hodgkin-Huxley model (1952, Nobel Prize 1963):</a:t>
+              <a:t>Hodgkin-Huxley model (1952; Nobel Prize in Physiology/Medicine 1963):</a:t>
             </a:r>
           </a:p>
           <a:p>
@@ -11461,68 +11537,84 @@
               </a:defRPr>
             </a:pPr>
             <a:r>
-              <a:t>AI can reduce timelines by 2-4 years and costs by 30-50% (McKinsey, 2021)</a:t>
-            </a:r>
-          </a:p>
-          <a:p>
-            <a:pPr>
-              <a:spcAft>
-                <a:spcPts val="800"/>
-              </a:spcAft>
-              <a:defRPr sz="2000">
-                <a:solidFill>
-                  <a:srgbClr val="323232"/>
-                </a:solidFill>
-                <a:latin typeface="Calibri"/>
-              </a:defRPr>
-            </a:pPr>
-          </a:p>
-          <a:p>
-            <a:pPr>
-              <a:spcAft>
-                <a:spcPts val="800"/>
-              </a:spcAft>
-              <a:defRPr sz="2000">
-                <a:solidFill>
-                  <a:srgbClr val="323232"/>
-                </a:solidFill>
-                <a:latin typeface="Calibri"/>
-              </a:defRPr>
-            </a:pPr>
-            <a:r>
-              <a:t>Case study: Insilico Medicine ISM001-055</a:t>
-            </a:r>
-          </a:p>
-          <a:p>
-            <a:pPr>
-              <a:spcAft>
-                <a:spcPts val="800"/>
-              </a:spcAft>
-              <a:defRPr sz="2000">
-                <a:solidFill>
-                  <a:srgbClr val="323232"/>
-                </a:solidFill>
-                <a:latin typeface="Calibri"/>
-              </a:defRPr>
-            </a:pPr>
-            <a:r>
-              <a:t>  First AI-designed drug to reach Phase II (2023)</a:t>
-            </a:r>
-          </a:p>
-          <a:p>
-            <a:pPr>
-              <a:spcAft>
-                <a:spcPts val="800"/>
-              </a:spcAft>
-              <a:defRPr sz="2000">
-                <a:solidFill>
-                  <a:srgbClr val="323232"/>
-                </a:solidFill>
-                <a:latin typeface="Calibri"/>
-              </a:defRPr>
-            </a:pPr>
-            <a:r>
-              <a:t>  Target to preclinical in 18 months (vs. 4-5 years) at ~$2.6M (vs. $100M+)</a:t>
+              <a:t>AI can compress timelines by years and reduce costs significantly</a:t>
+            </a:r>
+          </a:p>
+          <a:p>
+            <a:pPr>
+              <a:spcAft>
+                <a:spcPts val="800"/>
+              </a:spcAft>
+              <a:defRPr sz="2000">
+                <a:solidFill>
+                  <a:srgbClr val="323232"/>
+                </a:solidFill>
+                <a:latin typeface="Calibri"/>
+              </a:defRPr>
+            </a:pPr>
+            <a:r>
+              <a:t>  McKinsey/MGI (2020): 'The Bio Revolution' report + 2022 analyses</a:t>
+            </a:r>
+          </a:p>
+          <a:p>
+            <a:pPr>
+              <a:spcAft>
+                <a:spcPts val="800"/>
+              </a:spcAft>
+              <a:defRPr sz="2000">
+                <a:solidFill>
+                  <a:srgbClr val="323232"/>
+                </a:solidFill>
+                <a:latin typeface="Calibri"/>
+              </a:defRPr>
+            </a:pPr>
+          </a:p>
+          <a:p>
+            <a:pPr>
+              <a:spcAft>
+                <a:spcPts val="800"/>
+              </a:spcAft>
+              <a:defRPr sz="2000">
+                <a:solidFill>
+                  <a:srgbClr val="323232"/>
+                </a:solidFill>
+                <a:latin typeface="Calibri"/>
+              </a:defRPr>
+            </a:pPr>
+            <a:r>
+              <a:t>Case study: Insilico Medicine ISM001-055 (Rentosertib)</a:t>
+            </a:r>
+          </a:p>
+          <a:p>
+            <a:pPr>
+              <a:spcAft>
+                <a:spcPts val="800"/>
+              </a:spcAft>
+              <a:defRPr sz="2000">
+                <a:solidFill>
+                  <a:srgbClr val="323232"/>
+                </a:solidFill>
+                <a:latin typeface="Calibri"/>
+              </a:defRPr>
+            </a:pPr>
+            <a:r>
+              <a:t>  First AI-designed drug to reach Phase IIa (enrolled Apr 2023)</a:t>
+            </a:r>
+          </a:p>
+          <a:p>
+            <a:pPr>
+              <a:spcAft>
+                <a:spcPts val="800"/>
+              </a:spcAft>
+              <a:defRPr sz="2000">
+                <a:solidFill>
+                  <a:srgbClr val="323232"/>
+                </a:solidFill>
+                <a:latin typeface="Calibri"/>
+              </a:defRPr>
+            </a:pPr>
+            <a:r>
+              <a:t>  Target to Phase II in ~30 months (vs. 4-5 years typical)</a:t>
             </a:r>
           </a:p>
         </p:txBody>

</xml_diff>

<commit_message>
Remove name-dropping from slides, add 10-question intro quiz deck
- Removed all "Dr. Serbe-Kamp" references from slide text (kept in
  presenter notes and full citations like "Ammer, Serbe-Kamp et al.")
- Added quiz_intro/slides.pptx: 22 slides (1 title + 10 questions +
  10 answer reveals + 1 closing)
- Quiz covers: blockbuster drugs, drug history, target families,
  prescriptions, administration routes, vet vs human markets,
  lives saved, development timelines, magic bullet concept,
  therapeutic areas
- Each answer slide has detailed presenter notes with verified
  citations and full explanations for master-level audience

Agent-Logs-Url: https://github.com/ETigerschuss/AI-Drug-Discovery/sessions/aa676326-288c-488e-9e51-7ec8b2f397b9

Co-authored-by: ETigerschuss <3415055+ETigerschuss@users.noreply.github.com>
</commit_message>
<xml_diff>
--- a/day1_introduction/slides.pptx
+++ b/day1_introduction/slides.pptx
@@ -6375,7 +6375,7 @@
               </a:defRPr>
             </a:pPr>
             <a:r>
-              <a:t>This is where Dr. Serbe-Kamp's physiology expertise meets drug discovery</a:t>
+              <a:t>This is where physiology expertise meets drug discovery</a:t>
             </a:r>
           </a:p>
         </p:txBody>
@@ -6685,7 +6685,7 @@
               </a:defRPr>
             </a:pPr>
             <a:r>
-              <a:t>Dr. Serbe-Kamp's 2016 Neuron paper: steps 3-4 in Drosophila</a:t>
+              <a:t>Serbe et al. (2016) Neuron 89:829-841: steps 3-4 in Drosophila</a:t>
             </a:r>
           </a:p>
           <a:p>
@@ -7084,7 +7084,7 @@
               </a:defRPr>
             </a:pPr>
             <a:r>
-              <a:t>  Dr. Serbe-Kamp is Co-Director of Summer Fellowships at Backyard Brains</a:t>
+              <a:t>  BYB Summer Fellowships — citizen neuroscience at Backyard Brains</a:t>
             </a:r>
           </a:p>
           <a:p>
@@ -7145,7 +7145,7 @@
               </a:defRPr>
             </a:pPr>
             <a:r>
-              <a:t>  GluCl channels (from Dr. Serbe-Kamp's fly research) = ivermectin target!</a:t>
+              <a:t>  GluCl channels (Cys-loop receptor family, studied in Drosophila) = ivermectin target!</a:t>
             </a:r>
           </a:p>
           <a:p>
@@ -9981,7 +9981,7 @@
               </a:defRPr>
             </a:pPr>
             <a:r>
-              <a:t>  → Electrophysiology, calcium imaging = gold standard (Dr. Serbe-Kamp's expertise)</a:t>
+              <a:t>  → Electrophysiology, calcium imaging = gold standard for drug validation</a:t>
             </a:r>
           </a:p>
           <a:p>
@@ -10882,7 +10882,7 @@
               </a:defRPr>
             </a:pPr>
             <a:r>
-              <a:t>  → The same techniques Dr. Serbe-Kamp uses in his research!</a:t>
+              <a:t>  → The same techniques used in neuroscience research on ion channels!</a:t>
             </a:r>
           </a:p>
           <a:p>

</xml_diff>